<commit_message>
docs(rapport): 167 tests, incident d'en-tete n8n et mention de la video de demo
Le rapport installe (81 p.) et le deck alignes sur l'etat reel du code :
compte de test corrige (166 -> 167 methodes dans 16 classes, verifie dans
JOB4YOU-backend/src/test/java), troisieme defaillance du flux lien Meet
decrite en 4.5.10 (rappel parti sans en-tete d'authentification, reponse 401
silencieuse alors que l'execution n8n affichait success), et verification de
bout en bout accompagnee de la video de demonstration transmise a l'encadrant
en 4.4.4. Pagination et table des matieres inchangees.
</commit_message>
<xml_diff>
--- a/Rapport-PFE/finalreport/Soutenance_JOB4YOU_Haythem_Bargaoui.pptx
+++ b/Rapport-PFE/finalreport/Soutenance_JOB4YOU_Haythem_Bargaoui.pptx
@@ -515,7 +515,7 @@
           <a:p>
             <a:r>
               <a:rPr lang="zh-CN" dirty="0"/>
-              <a:t>45 s. Annoncer 166 methodes dans 16 classes, dont 4 tests de controleur avec MockMvc, et 22 cas de test manuel tous conformes. Citer les garde-fous verifies sur la decision a deux niveaux et sur le routage : un manager ne voit que les dossiers ou il est destinataire, la liste etant gelee a l'entree en evaluation technique. Etre honnete sur le reste a renforcer : integration, bout en bout, front-end, CI/CD.</a:t>
+              <a:t>45 s. Annoncer 167 methodes dans 16 classes, dont 4 tests de controleur avec MockMvc, et 22 cas de test manuel tous conformes. Citer les garde-fous verifies sur la decision a deux niveaux et sur le routage : un manager ne voit que les dossiers ou il est destinataire, la liste etant gelee a l'entree en evaluation technique. Etre honnete sur le reste a renforcer : integration, bout en bout, front-end, CI/CD.</a:t>
             </a:r>
           </a:p>
         </p:txBody>
@@ -7019,7 +7019,7 @@
                 <a:latin typeface="Arial"/>
                 <a:ea typeface="Arial"/>
               </a:rPr>
-              <a:t>166</a:t>
+              <a:t>167</a:t>
             </a:r>
           </a:p>
         </p:txBody>

</xml_diff>

<commit_message>
fix(scoring): noyau de scoring et de matching fiabilise, rapport et deck alignes sur le Gold Set 20 cas
- SkillNormalizationService: une competence citee sous une negation n'est plus
  comptee comme acquise dans matchedSkills (justification XAI lue par le RH)
- CandidateService: saveAiScore et recomputeAiScore partagent le meme chemin de
  decision (seuil, zone grise,needsHumanReview)
- AiScoringService / CohereClient / MatchingService: parsing de score plus
  strict et bornes explicites
- 3 nouvelles classes de test + tests de non-regression: 190 methodes dans 19
  classes
- gold_set: 4 cas limites (GOLD_17..20) et benchmark re-mesure sur 20 CV
  annotes (19 decisions justes sur 20, faux positif GOLD_18 assume)
- rapport Word/PDF: chapitre 4 re-aligne sur la re-mesure, zone grise jamais
  declenchee sur le Gold Set, compte des tests 190/19 (79 pages, TOC verifie)
- deck de soutenance: meme chiffres, conformite sans loi nationale
</commit_message>
<xml_diff>
--- a/Rapport-PFE/finalreport/Soutenance_JOB4YOU_Haythem_Bargaoui.pptx
+++ b/Rapport-PFE/finalreport/Soutenance_JOB4YOU_Haythem_Bargaoui.pptx
@@ -515,7 +515,7 @@
           <a:p>
             <a:r>
               <a:rPr lang="zh-CN" dirty="0"/>
-              <a:t>45 s. Annoncer 167 methodes dans 16 classes, dont 4 tests de controleur avec MockMvc, et 22 cas de test manuel tous conformes. Citer les garde-fous verifies sur la decision a deux niveaux et sur le routage : un manager ne voit que les dossiers ou il est destinataire, la liste etant gelee a l'entree en evaluation technique. Etre honnete sur le reste a renforcer : integration, bout en bout, front-end, CI/CD.</a:t>
+              <a:t>45 s. Annoncer 190 methodes dans 19 classes, dont 4 tests de controleur avec MockMvc, et 22 cas de test manuel tous conformes. Citer les garde-fous verifies sur la decision a deux niveaux et sur le routage : un manager ne voit que les dossiers ou il est destinataire, la liste etant gelee a l'entree en evaluation technique. Donner la mesure du seuil : Gold Set de vingt CV annotes, dix-neuf bonnes decisions sur vingt, un faux positif assume sur un profil DevOps a 71/100. Etre honnete sur le reste a renforcer : integration, bout en bout, front-end, CI/CD.</a:t>
             </a:r>
           </a:p>
         </p:txBody>
@@ -574,7 +574,7 @@
           <a:p>
             <a:r>
               <a:rPr lang="zh-CN" dirty="0"/>
-              <a:t>45 s. Montrer que la conformite a ete traitee serieusement : loi organique 2004-63 et INPDP, AI Act « haut risque », transferts vers des services tiers, politique de retention a definir. Conclure sur la formulation conditionnelle d'avancement.</a:t>
+              <a:t>45 s. Montrer que la conformite a ete traitee serieusement : RGPD article 22 et AI Act « haut risque », transferts vers des services tiers, politique de retention a definir. Conclure sur la formulation conditionnelle d'avancement.</a:t>
             </a:r>
           </a:p>
         </p:txBody>
@@ -7019,7 +7019,7 @@
                 <a:latin typeface="Arial"/>
                 <a:ea typeface="Arial"/>
               </a:rPr>
-              <a:t>167</a:t>
+              <a:t>190</a:t>
             </a:r>
           </a:p>
         </p:txBody>
@@ -7135,7 +7135,7 @@
                 <a:latin typeface="Arial"/>
                 <a:ea typeface="Arial"/>
               </a:rPr>
-              <a:t>16</a:t>
+              <a:t>19</a:t>
             </a:r>
           </a:p>
         </p:txBody>
@@ -7663,14 +7663,14 @@
           <a:p>
             <a:pPr algn="l"/>
             <a:r>
-              <a:rPr sz="1150">
+              <a:rPr sz="1200">
                 <a:solidFill>
                   <a:srgbClr val="9AA9BC"/>
                 </a:solidFill>
                 <a:latin typeface="Arial"/>
                 <a:ea typeface="Arial"/>
               </a:rPr>
-              <a:t>Détail des tests et des points relevés : chapitre 4 du rapport, sections 4.4 et 4.5.</a:t>
+              <a:t>Détail : chapitre 4 du rapport, sections 4.4 et 4.5 ; seuil de 60/100 mesuré sur un Gold Set de vingt CV annotés (19 décisions sur 20).</a:t>
             </a:r>
           </a:p>
         </p:txBody>
@@ -7967,7 +7967,7 @@
                 <a:latin typeface="Arial"/>
                 <a:ea typeface="Arial"/>
               </a:rPr>
-              <a:t>Loi organique n° 2004-63, sous le contrôle de l'INPDP : consentement recueilli au dépôt de la candidature.</a:t>
+              <a:t>RGPD (UE) 2016/679, article 22 : toute décision automatisée reste sous supervision humaine ; consentement recueilli au dépôt de la candidature.</a:t>
             </a:r>
           </a:p>
           <a:p>
@@ -8006,7 +8006,7 @@
                 <a:latin typeface="Arial"/>
                 <a:ea typeface="Arial"/>
               </a:rPr>
-              <a:t>Déjà couvert : supervision humaine, traçabilité des décisions, surcharge de score justifiée.</a:t>
+              <a:t>Déjà couvert : traçabilité des décisions dans le journal d'audit, surcharge de score justifiée, validation RH systématique.</a:t>
             </a:r>
           </a:p>
         </p:txBody>

</xml_diff>